<commit_message>
docs: update Vibe Coding v2 deck and handout v2
Co-Authored-By: Claude Sonnet 5 <noreply@anthropic.com>
</commit_message>
<xml_diff>
--- a/docs/TCA-Vibe-Coding-v2.pptx
+++ b/docs/TCA-Vibe-Coding-v2.pptx
@@ -18,12 +18,12 @@
     <p:sldId id="262" r:id="rId9"/>
     <p:sldId id="263" r:id="rId10"/>
     <p:sldId id="264" r:id="rId11"/>
-    <p:sldId id="276" r:id="rId25"/>
-    <p:sldId id="265" r:id="rId12"/>
-    <p:sldId id="266" r:id="rId13"/>
-    <p:sldId id="267" r:id="rId14"/>
-    <p:sldId id="268" r:id="rId15"/>
-    <p:sldId id="269" r:id="rId16"/>
+    <p:sldId id="276" r:id="rId12"/>
+    <p:sldId id="265" r:id="rId13"/>
+    <p:sldId id="266" r:id="rId14"/>
+    <p:sldId id="267" r:id="rId15"/>
+    <p:sldId id="268" r:id="rId16"/>
+    <p:sldId id="269" r:id="rId17"/>
     <p:sldId id="271" r:id="rId18"/>
     <p:sldId id="272" r:id="rId19"/>
   </p:sldIdLst>
@@ -528,37 +528,43 @@
           <a:p>
             <a:r>
               <a:rPr sz="1200"/>
-              <a:t>[18:30 · 2 min]  Four verbs, not a list of commands to memorise. See, load, trim, reset.</a:t>
+              <a:t>[16:30 · 2 min]  New in v2, and the one place today touches real risk. Do not cut this slide.</a:t>
             </a:r>
           </a:p>
           <a:p>
             <a:r>
               <a:rPr sz="1200"/>
-              <a:t>SEE. /context in Claude Code, /status in Codex. What is it holding right now, and how full is the window. When answers drift, check this before you re-explain anything.</a:t>
+              <a:t>Both tools ship an approvals dial. Claude Code: Shift+Tab cycles the mode, from asking every time, through accepting edits, to plan mode. Codex: /permissions, with read-only, workspace-write and danger-full-access underneath.</a:t>
             </a:r>
           </a:p>
           <a:p>
             <a:r>
               <a:rPr sz="1200"/>
-              <a:t>LOAD. @path. This is the half people skip. It is not a file-picker convenience, it is you deciding what goes into the window instead of letting the agent search and guess. The cheapest fix for a vague answer is usually loading the right file, not writing a longer prompt. Identical in both tools.</a:t>
+              <a:t>Left box: auto-accept everywhere is genuinely faster, right up until it is not. The failure is not that the agent did something insane. It is that you pre-approved a whole class of action and then were not in the room when it ran.</a:t>
             </a:r>
           </a:p>
           <a:p>
             <a:r>
               <a:rPr sz="1200"/>
-              <a:t>TRIM. /compact. Summarises the conversation and drops the stale detail, keeping the thread but reclaiming the space.</a:t>
+              <a:t>Right box: match the dial to the blast radius. Ask-every-time while the task is new. Auto-accept only inside a sandbox, or a repo you could delete without needing a conversation about it.</a:t>
             </a:r>
           </a:p>
           <a:p>
             <a:r>
               <a:rPr sz="1200"/>
-              <a:t>RESET. /clear in Claude Code, /new in Codex. New task means new window. Most people never reset, then blame the model.</a:t>
+              <a:t>Say this for the room going back to an employer's laptop on Monday: never auto-run destructive shell in a repository that matters. Not because the tool is reckless, but because you cannot un-run it.</a:t>
             </a:r>
           </a:p>
           <a:p>
             <a:r>
               <a:rPr sz="1200"/>
-              <a:t>Say out loud: ending a confused session is a senior habit, not an admission of defeat.</a:t>
+              <a:t>The line: permissions are a design decision, not a settings screen you skip.</a:t>
+            </a:r>
+          </a:p>
+          <a:p>
+            <a:r>
+              <a:rPr sz="1200"/>
+              <a:t>If asked about MCP servers or network access: same principle. You decide what it can reach, and every server you add costs context too.</a:t>
             </a:r>
           </a:p>
         </p:txBody>
@@ -587,11 +593,6 @@
         </p:txBody>
       </p:sp>
     </p:spTree>
-    <p:extLst>
-      <p:ext uri="{BB962C8B-B14F-4D97-AF65-F5344CB8AC3E}">
-        <p14:creationId xmlns:p14="http://schemas.microsoft.com/office/powerpoint/2010/main" val="1024086991"/>
-      </p:ext>
-    </p:extLst>
   </p:cSld>
   <p:clrMapOvr>
     <a:masterClrMapping/>
@@ -645,31 +646,37 @@
           <a:p>
             <a:r>
               <a:rPr sz="1200"/>
-              <a:t>[20:30 · 1.5 min]  The diagnostic for the cockpit you just showed them. Three states, each with a move attached.</a:t>
+              <a:t>[18:30 · 2 min]  Four verbs, not a list of commands to memorise. See, load, trim, reset.</a:t>
             </a:r>
           </a:p>
           <a:p>
             <a:r>
               <a:rPr sz="1200"/>
-              <a:t>Too little: it was never told enough, so it guesses. Wrong file, invented convention, confident nonsense. This failure looks like stupidity and is actually starvation. The move is LOAD.</a:t>
+              <a:t>SEE. /context in Claude Code, /status in Codex. What is it holding right now, and how full is the window. When answers drift, check this before you re-explain anything.</a:t>
             </a:r>
           </a:p>
           <a:p>
             <a:r>
               <a:rPr sz="1200"/>
-              <a:t>Just right: one task, only the files that task touches, nothing left over from an hour ago. The move is HOLD. This is where you want them living all morning.</a:t>
+              <a:t>LOAD. @path. This is the half people skip. It is not a file-picker convenience, it is you deciding what goes into the window instead of letting the agent search and guess. The cheapest fix for a vague answer is usually loading the right file, not writing a longer prompt. Identical in both tools.</a:t>
             </a:r>
           </a:p>
           <a:p>
             <a:r>
               <a:rPr sz="1200"/>
-              <a:t>Too much: the window is full, it is slow, and old threads bleed into new answers. The move is TRIM, then RESET if that is not enough.</a:t>
+              <a:t>TRIM. /compact. Summarises the conversation and drops the stale detail, keeping the thread but reclaiming the space.</a:t>
             </a:r>
           </a:p>
           <a:p>
             <a:r>
               <a:rPr sz="1200"/>
-              <a:t>Tie it back hard: when an answer goes vague or off topic, it is a context problem about nine times in ten. Check the gauge before you argue with the model.</a:t>
+              <a:t>RESET. /clear in Claude Code, /new in Codex. New task means new window. Most people never reset, then blame the model.</a:t>
+            </a:r>
+          </a:p>
+          <a:p>
+            <a:r>
+              <a:rPr sz="1200"/>
+              <a:t>Say out loud: ending a confused session is a senior habit, not an admission of defeat.</a:t>
             </a:r>
           </a:p>
         </p:txBody>
@@ -756,31 +763,31 @@
           <a:p>
             <a:r>
               <a:rPr sz="1200"/>
-              <a:t>[22:00 · 1.5 min]  The recovery loop, and the second most common place people grab the keyboard.</a:t>
+              <a:t>[20:30 · 1.5 min]  The diagnostic for the cockpit you just showed them. Three states, each with a move attached.</a:t>
             </a:r>
           </a:p>
           <a:p>
             <a:r>
               <a:rPr sz="1200"/>
-              <a:t>Left: hand-debugging. You open the file, read the trace, start editing. Two things just went wrong. You are typing again, and the agent now has no idea what you changed, so its next answer is based on a file that no longer exists as it remembers it.</a:t>
+              <a:t>Too little: it was never told enough, so it guesses. Wrong file, invented convention, confident nonsense. This failure looks like stupidity and is actually starvation. The move is LOAD.</a:t>
             </a:r>
           </a:p>
           <a:p>
             <a:r>
               <a:rPr sz="1200"/>
-              <a:t>Right: report symptoms. Paste the exact error text. Describe the screen in one line: "streak shows 3, I ticked it, still 3." Say what you saw, never what to change.</a:t>
+              <a:t>Just right: one task, only the files that task touches, nothing left over from an hour ago. The move is HOLD. This is where you want them living all morning.</a:t>
             </a:r>
           </a:p>
           <a:p>
             <a:r>
               <a:rPr sz="1200"/>
-              <a:t>The reason this works is not politeness. The agent reads a stack trace faster than you do, and it can read the logs, the file and the diff at the same time. Your advantage is knowing what wrong looks like on screen.</a:t>
+              <a:t>Too much: the window is full, it is slow, and old threads bleed into new answers. The move is TRIM, then RESET if that is not enough.</a:t>
             </a:r>
           </a:p>
           <a:p>
             <a:r>
               <a:rPr sz="1200"/>
-              <a:t>Set expectations: something will break for most of the room in Block B. That is scheduled, not bad luck.</a:t>
+              <a:t>Tie it back hard: when an answer goes vague or off topic, it is a context problem about nine times in ten. Check the gauge before you argue with the model.</a:t>
             </a:r>
           </a:p>
         </p:txBody>
@@ -867,25 +874,31 @@
           <a:p>
             <a:r>
               <a:rPr sz="1200"/>
-              <a:t>[23:30 · 1 min]  Short slide. git is your undo, and the agent can drive it.</a:t>
+              <a:t>[22:00 · 1.5 min]  The recovery loop, and the second most common place people grab the keyboard.</a:t>
             </a:r>
           </a:p>
           <a:p>
             <a:r>
               <a:rPr sz="1200"/>
-              <a:t>Say "commit this with a sensible message" and watch it stage, write the message and commit. Nobody needs to remember the flags.</a:t>
+              <a:t>Left: hand-debugging. You open the file, read the trace, start editing. Two things just went wrong. You are typing again, and the agent now has no idea what you changed, so its next answer is based on a file that no longer exists as it remembers it.</a:t>
             </a:r>
           </a:p>
           <a:p>
             <a:r>
               <a:rPr sz="1200"/>
-              <a:t>Two nets, and they will use both today. Small commits are yours: a bad turn is one revert away, no drama. The checkpoint is the room's: the reference repo holds a working app at the end of every section.</a:t>
+              <a:t>Right: report symptoms. Paste the exact error text. Describe the screen in one line: "streak shows 3, I ticked it, still 3." Say what you saw, never what to change.</a:t>
             </a:r>
           </a:p>
           <a:p>
             <a:r>
               <a:rPr sz="1200"/>
-              <a:t>Say it again here, because repetition is the whole point: using the net is expected, not failure.</a:t>
+              <a:t>The reason this works is not politeness. The agent reads a stack trace faster than you do, and it can read the logs, the file and the diff at the same time. Your advantage is knowing what wrong looks like on screen.</a:t>
+            </a:r>
+          </a:p>
+          <a:p>
+            <a:r>
+              <a:rPr sz="1200"/>
+              <a:t>Set expectations: something will break for most of the room in Block B. That is scheduled, not bad luck.</a:t>
             </a:r>
           </a:p>
         </p:txBody>
@@ -972,31 +985,25 @@
           <a:p>
             <a:r>
               <a:rPr sz="1200"/>
-              <a:t>[24:30 · 1.5 min]  Zoom out. This is the slide for anyone who has been away, and for the sceptic at the back.</a:t>
+              <a:t>[23:30 · 1 min]  Short slide. git is your undo, and the agent can drive it.</a:t>
             </a:r>
           </a:p>
           <a:p>
             <a:r>
               <a:rPr sz="1200"/>
-              <a:t>Planning: from "make it plan, then check the steps" to "it plans fine, check that it understood the right problem". Anchor to the earlier slide, do not re-teach it.</a:t>
+              <a:t>Say "commit this with a sensible message" and watch it stage, write the message and commit. Nobody needs to remember the flags.</a:t>
             </a:r>
           </a:p>
           <a:p>
             <a:r>
               <a:rPr sz="1200"/>
-              <a:t>Context: a year ago windows were small and you pruned constantly. Now they are repo-scale and memory persists, which is exactly what turned context engineering into a discipline rather than an afterthought.</a:t>
+              <a:t>Two nets, and they will use both today. Small commits are yours: a bad turn is one revert away, no drama. The checkpoint is the room's: the reference repo holds a working app at the end of every section.</a:t>
             </a:r>
           </a:p>
           <a:p>
             <a:r>
               <a:rPr sz="1200"/>
-              <a:t>Agents: a year ago it was you and one chat. Now both tools run teams. That is Section 3 this afternoon, so plant it and move.</a:t>
-            </a:r>
-          </a:p>
-          <a:p>
-            <a:r>
-              <a:rPr sz="1200"/>
-              <a:t>The close, and it is the through-line of the whole day: the models got better at the mechanics, so the human skill moved up the stack. Intent, context, verification. Which is also precisely why a returning engineer is not behind.</a:t>
+              <a:t>Say it again here, because repetition is the whole point: using the net is expected, not failure.</a:t>
             </a:r>
           </a:p>
         </p:txBody>
@@ -1019,6 +1026,117 @@
             <a:fld id="{F7021451-1387-4CA6-816F-3879F97B5CBC}" type="slidenum">
               <a:rPr lang="en-US"/>
               <a:t>15</a:t>
+            </a:fld>
+            <a:endParaRPr lang="en-US"/>
+          </a:p>
+        </p:txBody>
+      </p:sp>
+    </p:spTree>
+    <p:extLst>
+      <p:ext uri="{BB962C8B-B14F-4D97-AF65-F5344CB8AC3E}">
+        <p14:creationId xmlns:p14="http://schemas.microsoft.com/office/powerpoint/2010/main" val="1024086991"/>
+      </p:ext>
+    </p:extLst>
+  </p:cSld>
+  <p:clrMapOvr>
+    <a:masterClrMapping/>
+  </p:clrMapOvr>
+</p:notes>
+</file>
+
+<file path=ppt/notesSlides/notesSlide16.xml><?xml version="1.0" encoding="utf-8"?>
+<p:notes xmlns:a="http://schemas.openxmlformats.org/drawingml/2006/main" xmlns:r="http://schemas.openxmlformats.org/officeDocument/2006/relationships" xmlns:p="http://schemas.openxmlformats.org/presentationml/2006/main">
+  <p:cSld>
+    <p:spTree>
+      <p:nvGrpSpPr>
+        <p:cNvPr id="1" name=""/>
+        <p:cNvGrpSpPr/>
+        <p:nvPr/>
+      </p:nvGrpSpPr>
+      <p:grpSpPr>
+        <a:xfrm>
+          <a:off x="0" y="0"/>
+          <a:ext cx="0" cy="0"/>
+          <a:chOff x="0" y="0"/>
+          <a:chExt cx="0" cy="0"/>
+        </a:xfrm>
+      </p:grpSpPr>
+      <p:sp>
+        <p:nvSpPr>
+          <p:cNvPr id="2" name="Slide Image Placeholder 1"/>
+          <p:cNvSpPr>
+            <a:spLocks noGrp="1" noRot="1" noChangeAspect="1"/>
+          </p:cNvSpPr>
+          <p:nvPr>
+            <p:ph type="sldImg"/>
+          </p:nvPr>
+        </p:nvSpPr>
+        <p:spPr/>
+      </p:sp>
+      <p:sp>
+        <p:nvSpPr>
+          <p:cNvPr id="3" name="Notes Placeholder 2"/>
+          <p:cNvSpPr>
+            <a:spLocks noGrp="1"/>
+          </p:cNvSpPr>
+          <p:nvPr>
+            <p:ph type="body" idx="1"/>
+          </p:nvPr>
+        </p:nvSpPr>
+        <p:spPr/>
+        <p:txBody>
+          <a:bodyPr/>
+          <a:lstStyle/>
+          <a:p>
+            <a:r>
+              <a:rPr sz="1200"/>
+              <a:t>[24:30 · 1.5 min]  Zoom out. This is the slide for anyone who has been away, and for the sceptic at the back.</a:t>
+            </a:r>
+          </a:p>
+          <a:p>
+            <a:r>
+              <a:rPr sz="1200"/>
+              <a:t>Planning: from "make it plan, then check the steps" to "it plans fine, check that it understood the right problem". Anchor to the earlier slide, do not re-teach it.</a:t>
+            </a:r>
+          </a:p>
+          <a:p>
+            <a:r>
+              <a:rPr sz="1200"/>
+              <a:t>Context: a year ago windows were small and you pruned constantly. Now they are repo-scale and memory persists, which is exactly what turned context engineering into a discipline rather than an afterthought.</a:t>
+            </a:r>
+          </a:p>
+          <a:p>
+            <a:r>
+              <a:rPr sz="1200"/>
+              <a:t>Agents: a year ago it was you and one chat. Now both tools run teams. That is Section 3 this afternoon, so plant it and move.</a:t>
+            </a:r>
+          </a:p>
+          <a:p>
+            <a:r>
+              <a:rPr sz="1200"/>
+              <a:t>The close, and it is the through-line of the whole day: the models got better at the mechanics, so the human skill moved up the stack. Intent, context, verification. Which is also precisely why a returning engineer is not behind.</a:t>
+            </a:r>
+          </a:p>
+        </p:txBody>
+      </p:sp>
+      <p:sp>
+        <p:nvSpPr>
+          <p:cNvPr id="4" name="Slide Number Placeholder 3"/>
+          <p:cNvSpPr>
+            <a:spLocks noGrp="1"/>
+          </p:cNvSpPr>
+          <p:nvPr>
+            <p:ph type="sldNum" sz="quarter" idx="10"/>
+          </p:nvPr>
+        </p:nvSpPr>
+        <p:spPr/>
+        <p:txBody>
+          <a:bodyPr/>
+          <a:lstStyle/>
+          <a:p>
+            <a:fld id="{F7021451-1387-4CA6-816F-3879F97B5CBC}" type="slidenum">
+              <a:rPr lang="en-US"/>
+              <a:t>16</a:t>
             </a:fld>
             <a:endParaRPr lang="en-US"/>
           </a:p>
@@ -1241,124 +1359,6 @@
         <p14:creationId xmlns:p14="http://schemas.microsoft.com/office/powerpoint/2010/main" val="1024086991"/>
       </p:ext>
     </p:extLst>
-  </p:cSld>
-  <p:clrMapOvr>
-    <a:masterClrMapping/>
-  </p:clrMapOvr>
-</p:notes>
-</file>
-
-<file path=ppt/notesSlides/notesSlide19.xml><?xml version="1.0" encoding="utf-8"?>
-<p:notes xmlns:a="http://schemas.openxmlformats.org/drawingml/2006/main" xmlns:p="http://schemas.openxmlformats.org/presentationml/2006/main" xmlns:r="http://schemas.openxmlformats.org/officeDocument/2006/relationships">
-  <p:cSld>
-    <p:spTree>
-      <p:nvGrpSpPr>
-        <p:cNvPr id="1" name=""/>
-        <p:cNvGrpSpPr/>
-        <p:nvPr/>
-      </p:nvGrpSpPr>
-      <p:grpSpPr>
-        <a:xfrm>
-          <a:off x="0" y="0"/>
-          <a:ext cx="0" cy="0"/>
-          <a:chOff x="0" y="0"/>
-          <a:chExt cx="0" cy="0"/>
-        </a:xfrm>
-      </p:grpSpPr>
-      <p:sp>
-        <p:nvSpPr>
-          <p:cNvPr id="2" name="Slide Image Placeholder 1"/>
-          <p:cNvSpPr>
-            <a:spLocks noGrp="1" noRot="1" noChangeAspect="1"/>
-          </p:cNvSpPr>
-          <p:nvPr>
-            <p:ph type="sldImg"/>
-          </p:nvPr>
-        </p:nvSpPr>
-        <p:spPr/>
-      </p:sp>
-      <p:sp>
-        <p:nvSpPr>
-          <p:cNvPr id="3" name="Notes Placeholder 2"/>
-          <p:cNvSpPr>
-            <a:spLocks noGrp="1"/>
-          </p:cNvSpPr>
-          <p:nvPr>
-            <p:ph type="body" idx="1"/>
-          </p:nvPr>
-        </p:nvSpPr>
-        <p:spPr/>
-        <p:txBody>
-          <a:bodyPr/>
-          <a:lstStyle/>
-          <a:p>
-            <a:r>
-              <a:rPr sz="1200"/>
-              <a:t>[16:30 · 2 min]  New in v2, and the one place today touches real risk. Do not cut this slide.</a:t>
-            </a:r>
-          </a:p>
-          <a:p>
-            <a:r>
-              <a:rPr sz="1200"/>
-              <a:t>Both tools ship an approvals dial. Claude Code: Shift+Tab cycles the mode, from asking every time, through accepting edits, to plan mode. Codex: /permissions, with read-only, workspace-write and danger-full-access underneath.</a:t>
-            </a:r>
-          </a:p>
-          <a:p>
-            <a:r>
-              <a:rPr sz="1200"/>
-              <a:t>Left box: auto-accept everywhere is genuinely faster, right up until it is not. The failure is not that the agent did something insane. It is that you pre-approved a whole class of action and then were not in the room when it ran.</a:t>
-            </a:r>
-          </a:p>
-          <a:p>
-            <a:r>
-              <a:rPr sz="1200"/>
-              <a:t>Right box: match the dial to the blast radius. Ask-every-time while the task is new. Auto-accept only inside a sandbox, or a repo you could delete without needing a conversation about it.</a:t>
-            </a:r>
-          </a:p>
-          <a:p>
-            <a:r>
-              <a:rPr sz="1200"/>
-              <a:t>Say this for the room going back to an employer's laptop on Monday: never auto-run destructive shell in a repository that matters. Not because the tool is reckless, but because you cannot un-run it.</a:t>
-            </a:r>
-          </a:p>
-          <a:p>
-            <a:r>
-              <a:rPr sz="1200"/>
-              <a:t>The line: permissions are a design decision, not a settings screen you skip.</a:t>
-            </a:r>
-          </a:p>
-          <a:p>
-            <a:r>
-              <a:rPr sz="1200"/>
-              <a:t>If asked about MCP servers or network access: same principle. You decide what it can reach, and every server you add costs context too.</a:t>
-            </a:r>
-          </a:p>
-        </p:txBody>
-      </p:sp>
-      <p:sp>
-        <p:nvSpPr>
-          <p:cNvPr id="4" name="Slide Number Placeholder 3"/>
-          <p:cNvSpPr>
-            <a:spLocks noGrp="1"/>
-          </p:cNvSpPr>
-          <p:nvPr>
-            <p:ph type="sldNum" sz="quarter" idx="10"/>
-          </p:nvPr>
-        </p:nvSpPr>
-        <p:spPr/>
-        <p:txBody>
-          <a:bodyPr/>
-          <a:lstStyle/>
-          <a:p>
-            <a:fld id="{F7021451-1387-4CA6-816F-3879F97B5CBC}" type="slidenum">
-              <a:rPr lang="en-US"/>
-              <a:t>9</a:t>
-            </a:fld>
-            <a:endParaRPr lang="en-US"/>
-          </a:p>
-        </p:txBody>
-      </p:sp>
-    </p:spTree>
   </p:cSld>
   <p:clrMapOvr>
     <a:masterClrMapping/>
@@ -3528,7 +3528,7 @@
 </file>
 
 <file path=ppt/slides/slide11.xml><?xml version="1.0" encoding="utf-8"?>
-<p:sld xmlns:a="http://schemas.openxmlformats.org/drawingml/2006/main" xmlns:p="http://schemas.openxmlformats.org/presentationml/2006/main" xmlns:r="http://schemas.openxmlformats.org/officeDocument/2006/relationships">
+<p:sld xmlns:a="http://schemas.openxmlformats.org/drawingml/2006/main" xmlns:r="http://schemas.openxmlformats.org/officeDocument/2006/relationships" xmlns:p="http://schemas.openxmlformats.org/presentationml/2006/main">
   <p:cSld>
     <p:spTree>
       <p:nvGrpSpPr>
@@ -3536,7 +3536,14 @@
         <p:cNvGrpSpPr/>
         <p:nvPr/>
       </p:nvGrpSpPr>
-      <p:grpSpPr/>
+      <p:grpSpPr>
+        <a:xfrm>
+          <a:off x="0" y="0"/>
+          <a:ext cx="0" cy="0"/>
+          <a:chOff x="0" y="0"/>
+          <a:chExt cx="0" cy="0"/>
+        </a:xfrm>
+      </p:grpSpPr>
       <p:sp>
         <p:nvSpPr>
           <p:cNvPr id="2" name="Text 0"/>
@@ -3624,7 +3631,7 @@
           <p:nvPr/>
         </p:nvPicPr>
         <p:blipFill>
-          <a:blip r:embed="rId2"/>
+          <a:blip r:embed="rId3"/>
           <a:stretch>
             <a:fillRect/>
           </a:stretch>
@@ -13913,7 +13920,7 @@
         </p:nvSpPr>
         <p:spPr>
           <a:xfrm>
-            <a:off x="658368" y="1371600"/>
+            <a:off x="676656" y="1188720"/>
             <a:ext cx="5486400" cy="274320"/>
           </a:xfrm>
           <a:prstGeom prst="rect">

</xml_diff>